<commit_message>
Move lesson 8 to 27 November and align the README's lesson table
Lesson 8 is taught on 27 November and exercise 8 is discussed on
4 December, as SCHEDULE.md already said. The README's table of dates had
kept the first calendar; it now matches SCHEDULE.md row for row.

Co-Authored-By: Claude Opus 5.5 <noreply@anthropic.com>
</commit_message>
<xml_diff>
--- a/Lessons/08_unsupervised_learning/Slides/unsupervised_learning_slides.pptx
+++ b/Lessons/08_unsupervised_learning/Slides/unsupervised_learning_slides.pptx
@@ -6137,7 +6137,7 @@
             </a:pPr>
             <a:r>
               <a:rPr/>
-              <a:t>Set it explicitly and say when it comes back: the first ten minutes of lesson 9, Friday 27 November. Nothing is collected; at the exam one of the ten exercises is drawn and the student talks through their own notebook.</a:t>
+              <a:t>Set it explicitly and say when it comes back: the first ten minutes of lesson 9, Friday 4 December. Nothing is collected; at the exam one of the ten exercises is drawn and the student talks through their own notebook.</a:t>
             </a:r>
           </a:p>
           <a:p>
@@ -9730,7 +9730,7 @@
             </a:pPr>
             <a:r>
               <a:rPr/>
-              <a:t>20 November 2026</a:t>
+              <a:t>27 November 2026</a:t>
             </a:r>
           </a:p>
         </p:txBody>
@@ -15862,7 +15862,7 @@
             </a:r>
             <a:r>
               <a:rPr b="1"/>
-              <a:t>Friday 27 November</a:t>
+              <a:t>Friday 4 December</a:t>
             </a:r>
           </a:p>
           <a:p>

</xml_diff>